<commit_message>
Add slide for shapes demo in AbstractClasses
</commit_message>
<xml_diff>
--- a/ClassMaterials/AbstractClasses/Slides/Part1-AbstractClasses.pptx
+++ b/ClassMaterials/AbstractClasses/Slides/Part1-AbstractClasses.pptx
@@ -16,11 +16,11 @@
     <p:sldId id="369" r:id="rId7"/>
     <p:sldId id="397" r:id="rId8"/>
     <p:sldId id="379" r:id="rId9"/>
-    <p:sldId id="389" r:id="rId10"/>
-    <p:sldId id="388" r:id="rId11"/>
-    <p:sldId id="396" r:id="rId12"/>
-    <p:sldId id="381" r:id="rId13"/>
-    <p:sldId id="390" r:id="rId14"/>
+    <p:sldId id="398" r:id="rId10"/>
+    <p:sldId id="389" r:id="rId11"/>
+    <p:sldId id="388" r:id="rId12"/>
+    <p:sldId id="396" r:id="rId13"/>
+    <p:sldId id="381" r:id="rId14"/>
   </p:sldIdLst>
   <p:sldSz cx="9144000" cy="6858000" type="screen4x3"/>
   <p:notesSz cx="7010400" cy="9296400"/>
@@ -1079,6 +1079,98 @@
 </p:notes>
 </file>
 
+<file path=ppt/notesSlides/notesSlide10.xml><?xml version="1.0" encoding="utf-8"?>
+<p:notes xmlns:a="http://schemas.openxmlformats.org/drawingml/2006/main" xmlns:r="http://schemas.openxmlformats.org/officeDocument/2006/relationships" xmlns:p="http://schemas.openxmlformats.org/presentationml/2006/main">
+  <p:cSld>
+    <p:spTree>
+      <p:nvGrpSpPr>
+        <p:cNvPr id="1" name=""/>
+        <p:cNvGrpSpPr/>
+        <p:nvPr/>
+      </p:nvGrpSpPr>
+      <p:grpSpPr>
+        <a:xfrm>
+          <a:off x="0" y="0"/>
+          <a:ext cx="0" cy="0"/>
+          <a:chOff x="0" y="0"/>
+          <a:chExt cx="0" cy="0"/>
+        </a:xfrm>
+      </p:grpSpPr>
+      <p:sp>
+        <p:nvSpPr>
+          <p:cNvPr id="2" name="Slide Image Placeholder 1"/>
+          <p:cNvSpPr>
+            <a:spLocks noGrp="1" noRot="1" noChangeAspect="1"/>
+          </p:cNvSpPr>
+          <p:nvPr>
+            <p:ph type="sldImg"/>
+          </p:nvPr>
+        </p:nvSpPr>
+        <p:spPr/>
+      </p:sp>
+      <p:sp>
+        <p:nvSpPr>
+          <p:cNvPr id="3" name="Notes Placeholder 2"/>
+          <p:cNvSpPr>
+            <a:spLocks noGrp="1"/>
+          </p:cNvSpPr>
+          <p:nvPr>
+            <p:ph type="body" idx="1"/>
+          </p:nvPr>
+        </p:nvSpPr>
+        <p:spPr/>
+        <p:txBody>
+          <a:bodyPr>
+            <a:normAutofit/>
+          </a:bodyPr>
+          <a:lstStyle/>
+          <a:p>
+            <a:endParaRPr lang="en-US"/>
+          </a:p>
+        </p:txBody>
+      </p:sp>
+      <p:sp>
+        <p:nvSpPr>
+          <p:cNvPr id="4" name="Slide Number Placeholder 3"/>
+          <p:cNvSpPr>
+            <a:spLocks noGrp="1"/>
+          </p:cNvSpPr>
+          <p:nvPr>
+            <p:ph type="sldNum" sz="quarter" idx="10"/>
+          </p:nvPr>
+        </p:nvSpPr>
+        <p:spPr/>
+        <p:txBody>
+          <a:bodyPr/>
+          <a:lstStyle/>
+          <a:p>
+            <a:pPr>
+              <a:defRPr/>
+            </a:pPr>
+            <a:fld id="{3A187583-0EC9-4694-9EAD-0DA64A27677E}" type="slidenum">
+              <a:rPr lang="en-US" smtClean="0"/>
+              <a:pPr>
+                <a:defRPr/>
+              </a:pPr>
+              <a:t>10</a:t>
+            </a:fld>
+            <a:endParaRPr lang="en-US"/>
+          </a:p>
+        </p:txBody>
+      </p:sp>
+    </p:spTree>
+    <p:extLst>
+      <p:ext uri="{BB962C8B-B14F-4D97-AF65-F5344CB8AC3E}">
+        <p14:creationId xmlns:p14="http://schemas.microsoft.com/office/powerpoint/2010/main" val="254997008"/>
+      </p:ext>
+    </p:extLst>
+  </p:cSld>
+  <p:clrMapOvr>
+    <a:masterClrMapping/>
+  </p:clrMapOvr>
+</p:notes>
+</file>
+
 <file path=ppt/notesSlides/notesSlide2.xml><?xml version="1.0" encoding="utf-8"?>
 <p:notes xmlns:a="http://schemas.openxmlformats.org/drawingml/2006/main" xmlns:r="http://schemas.openxmlformats.org/officeDocument/2006/relationships" xmlns:p="http://schemas.openxmlformats.org/presentationml/2006/main">
   <p:cSld>
@@ -1555,61 +1647,21 @@
           <a:lstStyle/>
           <a:p>
             <a:r>
-              <a:rPr lang="en-US" baseline="0" dirty="0"/>
-              <a:t>Walk through the Chess example in Inheritance project. Start by showing the King and </a:t>
-            </a:r>
-            <a:r>
-              <a:rPr lang="en-US" baseline="0" dirty="0" err="1"/>
-              <a:t>ChessPiece</a:t>
-            </a:r>
-            <a:r>
-              <a:rPr lang="en-US" baseline="0" dirty="0"/>
-              <a:t> interface. Implement the queen, and note to the students how we end up copying a lot of code from the King into the Queen, there has to be a better way…</a:t>
-            </a:r>
-          </a:p>
-          <a:p>
-            <a:endParaRPr lang="en-US" baseline="0" dirty="0"/>
-          </a:p>
-          <a:p>
-            <a:r>
-              <a:rPr lang="en-US" baseline="0" dirty="0"/>
-              <a:t>It works well to just make the </a:t>
-            </a:r>
-            <a:r>
-              <a:rPr lang="en-US" baseline="0" dirty="0" err="1"/>
-              <a:t>ChessPiece</a:t>
-            </a:r>
-            <a:r>
-              <a:rPr lang="en-US" baseline="0" dirty="0"/>
-              <a:t> a class first and put in a </a:t>
-            </a:r>
-            <a:r>
-              <a:rPr lang="en-US" baseline="0" dirty="0" err="1"/>
-              <a:t>System.err.println</a:t>
-            </a:r>
-            <a:r>
-              <a:rPr lang="en-US" baseline="0" dirty="0"/>
-              <a:t>(“Implement this method!”) then show them if we forget to implement a method (Queen’s </a:t>
-            </a:r>
-            <a:r>
-              <a:rPr lang="en-US" baseline="0" dirty="0" err="1"/>
-              <a:t>checkMove</a:t>
-            </a:r>
-            <a:r>
-              <a:rPr lang="en-US" baseline="0" dirty="0"/>
-              <a:t>) we see that message at runtime.</a:t>
-            </a:r>
-          </a:p>
-          <a:p>
-            <a:endParaRPr lang="en-US" baseline="0" dirty="0"/>
-          </a:p>
-          <a:p>
-            <a:r>
-              <a:rPr lang="en-US" sz="1400" baseline="0" dirty="0"/>
-              <a:t>At this point, they should see the justification for an abstract class, show that on next slide</a:t>
-            </a:r>
-          </a:p>
-          <a:p>
+              <a:rPr lang="en-US" dirty="0"/>
+              <a:t>UML in </a:t>
+            </a:r>
+            <a:r>
+              <a:rPr lang="en-US" dirty="0" err="1"/>
+              <a:t>src</a:t>
+            </a:r>
+            <a:r>
+              <a:rPr lang="en-US" dirty="0"/>
+              <a:t>/shapes/</a:t>
+            </a:r>
+            <a:r>
+              <a:rPr lang="en-US" dirty="0" err="1"/>
+              <a:t>ShapeDesign.puml</a:t>
+            </a:r>
             <a:endParaRPr lang="en-US" dirty="0"/>
           </a:p>
         </p:txBody>
@@ -1621,7 +1673,7 @@
             <a:spLocks noGrp="1"/>
           </p:cNvSpPr>
           <p:nvPr>
-            <p:ph type="sldNum" sz="quarter" idx="10"/>
+            <p:ph type="sldNum" sz="quarter" idx="5"/>
           </p:nvPr>
         </p:nvSpPr>
         <p:spPr/>
@@ -1646,7 +1698,7 @@
     </p:spTree>
     <p:extLst>
       <p:ext uri="{BB962C8B-B14F-4D97-AF65-F5344CB8AC3E}">
-        <p14:creationId xmlns:p14="http://schemas.microsoft.com/office/powerpoint/2010/main" val="220594822"/>
+        <p14:creationId xmlns:p14="http://schemas.microsoft.com/office/powerpoint/2010/main" val="148387986"/>
       </p:ext>
     </p:extLst>
   </p:cSld>
@@ -1701,520 +1753,61 @@
           <a:lstStyle/>
           <a:p>
             <a:r>
-              <a:rPr lang="en-US" sz="1200" kern="1200" dirty="0">
-                <a:solidFill>
-                  <a:schemeClr val="tx1"/>
-                </a:solidFill>
-                <a:latin typeface="+mn-lt"/>
-                <a:ea typeface="+mn-ea"/>
-                <a:cs typeface="+mn-cs"/>
-              </a:rPr>
-              <a:t>Emphasize</a:t>
-            </a:r>
-            <a:r>
-              <a:rPr lang="en-US" sz="1200" kern="1200" baseline="0" dirty="0">
-                <a:solidFill>
-                  <a:schemeClr val="tx1"/>
-                </a:solidFill>
-                <a:latin typeface="+mn-lt"/>
-                <a:ea typeface="+mn-ea"/>
-                <a:cs typeface="+mn-cs"/>
-              </a:rPr>
-              <a:t> doing Pawn last it requires several things (</a:t>
-            </a:r>
-            <a:r>
-              <a:rPr lang="en-US" sz="1200" kern="1200" baseline="0" dirty="0" err="1">
-                <a:solidFill>
-                  <a:schemeClr val="tx1"/>
-                </a:solidFill>
-                <a:latin typeface="+mn-lt"/>
-                <a:ea typeface="+mn-ea"/>
-                <a:cs typeface="+mn-cs"/>
-              </a:rPr>
-              <a:t>hasMoved</a:t>
-            </a:r>
-            <a:r>
-              <a:rPr lang="en-US" sz="1200" kern="1200" baseline="0" dirty="0">
-                <a:solidFill>
-                  <a:schemeClr val="tx1"/>
-                </a:solidFill>
-                <a:latin typeface="+mn-lt"/>
-                <a:ea typeface="+mn-ea"/>
-                <a:cs typeface="+mn-cs"/>
-              </a:rPr>
-              <a:t> field) and needs to override the </a:t>
-            </a:r>
-            <a:r>
-              <a:rPr lang="en-US" sz="1200" kern="1200" baseline="0" dirty="0" err="1">
-                <a:solidFill>
-                  <a:schemeClr val="tx1"/>
-                </a:solidFill>
-                <a:latin typeface="+mn-lt"/>
-                <a:ea typeface="+mn-ea"/>
-                <a:cs typeface="+mn-cs"/>
-              </a:rPr>
-              <a:t>checkAttack</a:t>
-            </a:r>
-            <a:r>
-              <a:rPr lang="en-US" sz="1200" kern="1200" baseline="0" dirty="0">
-                <a:solidFill>
-                  <a:schemeClr val="tx1"/>
-                </a:solidFill>
-                <a:latin typeface="+mn-lt"/>
-                <a:ea typeface="+mn-ea"/>
-                <a:cs typeface="+mn-cs"/>
-              </a:rPr>
-              <a:t> method which is not obvious without looking at more code than they usually have to look at for the rest of the classes.</a:t>
-            </a:r>
-            <a:endParaRPr lang="en-US" sz="1200" kern="1200" dirty="0">
-              <a:solidFill>
-                <a:schemeClr val="tx1"/>
-              </a:solidFill>
-              <a:latin typeface="+mn-lt"/>
-              <a:ea typeface="+mn-ea"/>
-              <a:cs typeface="+mn-cs"/>
-            </a:endParaRPr>
-          </a:p>
-          <a:p>
-            <a:endParaRPr lang="en-US" sz="1200" kern="1200" dirty="0">
-              <a:solidFill>
-                <a:schemeClr val="tx1"/>
-              </a:solidFill>
-              <a:latin typeface="+mn-lt"/>
-              <a:ea typeface="+mn-ea"/>
-              <a:cs typeface="+mn-cs"/>
-            </a:endParaRPr>
-          </a:p>
-          <a:p>
-            <a:r>
-              <a:rPr lang="en-US" sz="1200" kern="1200" dirty="0">
-                <a:solidFill>
-                  <a:schemeClr val="tx1"/>
-                </a:solidFill>
-                <a:latin typeface="+mn-lt"/>
-                <a:ea typeface="+mn-ea"/>
-                <a:cs typeface="+mn-cs"/>
-              </a:rPr>
-              <a:t>@Override </a:t>
-            </a:r>
-          </a:p>
-          <a:p>
-            <a:r>
-              <a:rPr lang="en-US" sz="1200" b="1" kern="1200" dirty="0">
-                <a:solidFill>
-                  <a:schemeClr val="tx1"/>
-                </a:solidFill>
-                <a:latin typeface="+mn-lt"/>
-                <a:ea typeface="+mn-ea"/>
-                <a:cs typeface="+mn-cs"/>
-              </a:rPr>
-              <a:t>public </a:t>
-            </a:r>
-            <a:r>
-              <a:rPr lang="en-US" sz="1200" b="1" kern="1200" dirty="0" err="1">
-                <a:solidFill>
-                  <a:schemeClr val="tx1"/>
-                </a:solidFill>
-                <a:latin typeface="+mn-lt"/>
-                <a:ea typeface="+mn-ea"/>
-                <a:cs typeface="+mn-cs"/>
-              </a:rPr>
-              <a:t>boolean</a:t>
-            </a:r>
-            <a:r>
-              <a:rPr lang="en-US" sz="1200" b="1" kern="1200" dirty="0">
-                <a:solidFill>
-                  <a:schemeClr val="tx1"/>
-                </a:solidFill>
-                <a:latin typeface="+mn-lt"/>
-                <a:ea typeface="+mn-ea"/>
-                <a:cs typeface="+mn-cs"/>
-              </a:rPr>
-              <a:t> </a:t>
-            </a:r>
-            <a:r>
-              <a:rPr lang="en-US" sz="1200" b="1" kern="1200" dirty="0" err="1">
-                <a:solidFill>
-                  <a:schemeClr val="tx1"/>
-                </a:solidFill>
-                <a:latin typeface="+mn-lt"/>
-                <a:ea typeface="+mn-ea"/>
-                <a:cs typeface="+mn-cs"/>
-              </a:rPr>
-              <a:t>checkAttack</a:t>
-            </a:r>
-            <a:r>
-              <a:rPr lang="en-US" sz="1200" b="1" kern="1200" dirty="0">
-                <a:solidFill>
-                  <a:schemeClr val="tx1"/>
-                </a:solidFill>
-                <a:latin typeface="+mn-lt"/>
-                <a:ea typeface="+mn-ea"/>
-                <a:cs typeface="+mn-cs"/>
-              </a:rPr>
-              <a:t>(int dx, int </a:t>
-            </a:r>
-            <a:r>
-              <a:rPr lang="en-US" sz="1200" b="1" kern="1200" dirty="0" err="1">
-                <a:solidFill>
-                  <a:schemeClr val="tx1"/>
-                </a:solidFill>
-                <a:latin typeface="+mn-lt"/>
-                <a:ea typeface="+mn-ea"/>
-                <a:cs typeface="+mn-cs"/>
-              </a:rPr>
-              <a:t>dy</a:t>
-            </a:r>
-            <a:r>
-              <a:rPr lang="en-US" sz="1200" b="1" kern="1200" dirty="0">
-                <a:solidFill>
-                  <a:schemeClr val="tx1"/>
-                </a:solidFill>
-                <a:latin typeface="+mn-lt"/>
-                <a:ea typeface="+mn-ea"/>
-                <a:cs typeface="+mn-cs"/>
-              </a:rPr>
-              <a:t>, </a:t>
-            </a:r>
-            <a:r>
-              <a:rPr lang="en-US" sz="1200" b="1" kern="1200" dirty="0" err="1">
-                <a:solidFill>
-                  <a:schemeClr val="tx1"/>
-                </a:solidFill>
-                <a:latin typeface="+mn-lt"/>
-                <a:ea typeface="+mn-ea"/>
-                <a:cs typeface="+mn-cs"/>
-              </a:rPr>
+              <a:rPr lang="en-US" baseline="0" dirty="0"/>
+              <a:t>Walk through the Chess example in Inheritance project. Start by showing the King and </a:t>
+            </a:r>
+            <a:r>
+              <a:rPr lang="en-US" baseline="0" dirty="0" err="1"/>
               <a:t>ChessPiece</a:t>
             </a:r>
             <a:r>
-              <a:rPr lang="en-US" sz="1200" b="1" kern="1200" dirty="0">
-                <a:solidFill>
-                  <a:schemeClr val="tx1"/>
-                </a:solidFill>
-                <a:latin typeface="+mn-lt"/>
-                <a:ea typeface="+mn-ea"/>
-                <a:cs typeface="+mn-cs"/>
-              </a:rPr>
-              <a:t> piece) {</a:t>
-            </a:r>
-          </a:p>
-          <a:p>
-            <a:r>
-              <a:rPr lang="en-US" sz="1200" b="1" kern="1200" dirty="0">
-                <a:solidFill>
-                  <a:schemeClr val="tx1"/>
-                </a:solidFill>
-                <a:latin typeface="+mn-lt"/>
-                <a:ea typeface="+mn-ea"/>
-                <a:cs typeface="+mn-cs"/>
-              </a:rPr>
-              <a:t>if (</a:t>
-            </a:r>
-            <a:r>
-              <a:rPr lang="en-US" sz="1200" b="1" kern="1200" dirty="0" err="1">
-                <a:solidFill>
-                  <a:schemeClr val="tx1"/>
-                </a:solidFill>
-                <a:latin typeface="+mn-lt"/>
-                <a:ea typeface="+mn-ea"/>
-                <a:cs typeface="+mn-cs"/>
-              </a:rPr>
-              <a:t>this.isWhite</a:t>
-            </a:r>
-            <a:r>
-              <a:rPr lang="en-US" sz="1200" b="1" kern="1200" dirty="0">
-                <a:solidFill>
-                  <a:schemeClr val="tx1"/>
-                </a:solidFill>
-                <a:latin typeface="+mn-lt"/>
-                <a:ea typeface="+mn-ea"/>
-                <a:cs typeface="+mn-cs"/>
-              </a:rPr>
-              <a:t>() == </a:t>
-            </a:r>
-            <a:r>
-              <a:rPr lang="en-US" sz="1200" b="1" kern="1200" dirty="0" err="1">
-                <a:solidFill>
-                  <a:schemeClr val="tx1"/>
-                </a:solidFill>
-                <a:latin typeface="+mn-lt"/>
-                <a:ea typeface="+mn-ea"/>
-                <a:cs typeface="+mn-cs"/>
-              </a:rPr>
-              <a:t>piece.isWhite</a:t>
-            </a:r>
-            <a:r>
-              <a:rPr lang="en-US" sz="1200" b="1" kern="1200" dirty="0">
-                <a:solidFill>
-                  <a:schemeClr val="tx1"/>
-                </a:solidFill>
-                <a:latin typeface="+mn-lt"/>
-                <a:ea typeface="+mn-ea"/>
-                <a:cs typeface="+mn-cs"/>
-              </a:rPr>
-              <a:t>()) {</a:t>
-            </a:r>
-          </a:p>
-          <a:p>
-            <a:r>
-              <a:rPr lang="en-US" sz="1200" b="1" kern="1200" dirty="0">
-                <a:solidFill>
-                  <a:schemeClr val="tx1"/>
-                </a:solidFill>
-                <a:latin typeface="+mn-lt"/>
-                <a:ea typeface="+mn-ea"/>
-                <a:cs typeface="+mn-cs"/>
-              </a:rPr>
-              <a:t>return false;</a:t>
-            </a:r>
-          </a:p>
-          <a:p>
-            <a:r>
-              <a:rPr lang="en-US" sz="1200" kern="1200" dirty="0">
-                <a:solidFill>
-                  <a:schemeClr val="tx1"/>
-                </a:solidFill>
-                <a:latin typeface="+mn-lt"/>
-                <a:ea typeface="+mn-ea"/>
-                <a:cs typeface="+mn-cs"/>
-              </a:rPr>
-              <a:t>}</a:t>
-            </a:r>
-          </a:p>
-          <a:p>
-            <a:r>
-              <a:rPr lang="en-US" sz="1200" b="1" kern="1200" dirty="0">
-                <a:solidFill>
-                  <a:schemeClr val="tx1"/>
-                </a:solidFill>
-                <a:latin typeface="+mn-lt"/>
-                <a:ea typeface="+mn-ea"/>
-                <a:cs typeface="+mn-cs"/>
-              </a:rPr>
-              <a:t>if (!</a:t>
-            </a:r>
-            <a:r>
-              <a:rPr lang="en-US" sz="1200" b="1" kern="1200" dirty="0" err="1">
-                <a:solidFill>
-                  <a:schemeClr val="tx1"/>
-                </a:solidFill>
-                <a:latin typeface="+mn-lt"/>
-                <a:ea typeface="+mn-ea"/>
-                <a:cs typeface="+mn-cs"/>
-              </a:rPr>
-              <a:t>movedCorrectDirection</a:t>
-            </a:r>
-            <a:r>
-              <a:rPr lang="en-US" sz="1200" b="1" kern="1200" dirty="0">
-                <a:solidFill>
-                  <a:schemeClr val="tx1"/>
-                </a:solidFill>
-                <a:latin typeface="+mn-lt"/>
-                <a:ea typeface="+mn-ea"/>
-                <a:cs typeface="+mn-cs"/>
-              </a:rPr>
-              <a:t>(</a:t>
-            </a:r>
-            <a:r>
-              <a:rPr lang="en-US" sz="1200" b="1" kern="1200" dirty="0" err="1">
-                <a:solidFill>
-                  <a:schemeClr val="tx1"/>
-                </a:solidFill>
-                <a:latin typeface="+mn-lt"/>
-                <a:ea typeface="+mn-ea"/>
-                <a:cs typeface="+mn-cs"/>
-              </a:rPr>
-              <a:t>dy</a:t>
-            </a:r>
-            <a:r>
-              <a:rPr lang="en-US" sz="1200" b="1" kern="1200" dirty="0">
-                <a:solidFill>
-                  <a:schemeClr val="tx1"/>
-                </a:solidFill>
-                <a:latin typeface="+mn-lt"/>
-                <a:ea typeface="+mn-ea"/>
-                <a:cs typeface="+mn-cs"/>
-              </a:rPr>
-              <a:t>)) {</a:t>
-            </a:r>
-          </a:p>
-          <a:p>
-            <a:r>
-              <a:rPr lang="en-US" sz="1200" b="1" kern="1200" dirty="0">
-                <a:solidFill>
-                  <a:schemeClr val="tx1"/>
-                </a:solidFill>
-                <a:latin typeface="+mn-lt"/>
-                <a:ea typeface="+mn-ea"/>
-                <a:cs typeface="+mn-cs"/>
-              </a:rPr>
-              <a:t>return false;</a:t>
-            </a:r>
-          </a:p>
-          <a:p>
-            <a:r>
-              <a:rPr lang="en-US" sz="1200" kern="1200" dirty="0">
-                <a:solidFill>
-                  <a:schemeClr val="tx1"/>
-                </a:solidFill>
-                <a:latin typeface="+mn-lt"/>
-                <a:ea typeface="+mn-ea"/>
-                <a:cs typeface="+mn-cs"/>
-              </a:rPr>
-              <a:t>}</a:t>
-            </a:r>
-          </a:p>
-          <a:p>
-            <a:r>
-              <a:rPr lang="en-US" sz="1200" kern="1200" dirty="0">
-                <a:solidFill>
-                  <a:schemeClr val="tx1"/>
-                </a:solidFill>
-                <a:latin typeface="+mn-lt"/>
-                <a:ea typeface="+mn-ea"/>
-                <a:cs typeface="+mn-cs"/>
-              </a:rPr>
-              <a:t>dx = </a:t>
-            </a:r>
-            <a:r>
-              <a:rPr lang="en-US" sz="1200" kern="1200" dirty="0" err="1">
-                <a:solidFill>
-                  <a:schemeClr val="tx1"/>
-                </a:solidFill>
-                <a:latin typeface="+mn-lt"/>
-                <a:ea typeface="+mn-ea"/>
-                <a:cs typeface="+mn-cs"/>
-              </a:rPr>
-              <a:t>Math.abs</a:t>
-            </a:r>
-            <a:r>
-              <a:rPr lang="en-US" sz="1200" kern="1200" dirty="0">
-                <a:solidFill>
-                  <a:schemeClr val="tx1"/>
-                </a:solidFill>
-                <a:latin typeface="+mn-lt"/>
-                <a:ea typeface="+mn-ea"/>
-                <a:cs typeface="+mn-cs"/>
-              </a:rPr>
-              <a:t>(dx);</a:t>
-            </a:r>
-          </a:p>
-          <a:p>
-            <a:r>
-              <a:rPr lang="en-US" sz="1200" kern="1200" dirty="0" err="1">
-                <a:solidFill>
-                  <a:schemeClr val="tx1"/>
-                </a:solidFill>
-                <a:latin typeface="+mn-lt"/>
-                <a:ea typeface="+mn-ea"/>
-                <a:cs typeface="+mn-cs"/>
-              </a:rPr>
-              <a:t>dy</a:t>
-            </a:r>
-            <a:r>
-              <a:rPr lang="en-US" sz="1200" kern="1200" dirty="0">
-                <a:solidFill>
-                  <a:schemeClr val="tx1"/>
-                </a:solidFill>
-                <a:latin typeface="+mn-lt"/>
-                <a:ea typeface="+mn-ea"/>
-                <a:cs typeface="+mn-cs"/>
-              </a:rPr>
-              <a:t> = </a:t>
-            </a:r>
-            <a:r>
-              <a:rPr lang="en-US" sz="1200" kern="1200" dirty="0" err="1">
-                <a:solidFill>
-                  <a:schemeClr val="tx1"/>
-                </a:solidFill>
-                <a:latin typeface="+mn-lt"/>
-                <a:ea typeface="+mn-ea"/>
-                <a:cs typeface="+mn-cs"/>
-              </a:rPr>
-              <a:t>Math.abs</a:t>
-            </a:r>
-            <a:r>
-              <a:rPr lang="en-US" sz="1200" kern="1200" dirty="0">
-                <a:solidFill>
-                  <a:schemeClr val="tx1"/>
-                </a:solidFill>
-                <a:latin typeface="+mn-lt"/>
-                <a:ea typeface="+mn-ea"/>
-                <a:cs typeface="+mn-cs"/>
-              </a:rPr>
-              <a:t>(</a:t>
-            </a:r>
-            <a:r>
-              <a:rPr lang="en-US" sz="1200" kern="1200" dirty="0" err="1">
-                <a:solidFill>
-                  <a:schemeClr val="tx1"/>
-                </a:solidFill>
-                <a:latin typeface="+mn-lt"/>
-                <a:ea typeface="+mn-ea"/>
-                <a:cs typeface="+mn-cs"/>
-              </a:rPr>
-              <a:t>dy</a:t>
-            </a:r>
-            <a:r>
-              <a:rPr lang="en-US" sz="1200" kern="1200" dirty="0">
-                <a:solidFill>
-                  <a:schemeClr val="tx1"/>
-                </a:solidFill>
-                <a:latin typeface="+mn-lt"/>
-                <a:ea typeface="+mn-ea"/>
-                <a:cs typeface="+mn-cs"/>
-              </a:rPr>
-              <a:t>);</a:t>
-            </a:r>
-          </a:p>
-          <a:p>
-            <a:r>
-              <a:rPr lang="en-US" sz="1200" b="1" kern="1200" dirty="0">
-                <a:solidFill>
-                  <a:schemeClr val="tx1"/>
-                </a:solidFill>
-                <a:latin typeface="+mn-lt"/>
-                <a:ea typeface="+mn-ea"/>
-                <a:cs typeface="+mn-cs"/>
-              </a:rPr>
-              <a:t>return dx == 1 &amp;&amp; </a:t>
-            </a:r>
-            <a:r>
-              <a:rPr lang="en-US" sz="1200" b="1" kern="1200" dirty="0" err="1">
-                <a:solidFill>
-                  <a:schemeClr val="tx1"/>
-                </a:solidFill>
-                <a:latin typeface="+mn-lt"/>
-                <a:ea typeface="+mn-ea"/>
-                <a:cs typeface="+mn-cs"/>
-              </a:rPr>
-              <a:t>dy</a:t>
-            </a:r>
-            <a:r>
-              <a:rPr lang="en-US" sz="1200" b="1" kern="1200" dirty="0">
-                <a:solidFill>
-                  <a:schemeClr val="tx1"/>
-                </a:solidFill>
-                <a:latin typeface="+mn-lt"/>
-                <a:ea typeface="+mn-ea"/>
-                <a:cs typeface="+mn-cs"/>
-              </a:rPr>
-              <a:t> == 1;</a:t>
-            </a:r>
-          </a:p>
-          <a:p>
-            <a:r>
-              <a:rPr lang="en-US" sz="1200" kern="1200" dirty="0">
-                <a:solidFill>
-                  <a:schemeClr val="tx1"/>
-                </a:solidFill>
-                <a:latin typeface="+mn-lt"/>
-                <a:ea typeface="+mn-ea"/>
-                <a:cs typeface="+mn-cs"/>
-              </a:rPr>
-              <a:t>}</a:t>
-            </a:r>
+              <a:rPr lang="en-US" baseline="0" dirty="0"/>
+              <a:t> interface. Implement the queen, and note to the students how we end up copying a lot of code from the King into the Queen, there has to be a better way…</a:t>
+            </a:r>
+          </a:p>
+          <a:p>
+            <a:endParaRPr lang="en-US" baseline="0" dirty="0"/>
+          </a:p>
+          <a:p>
+            <a:r>
+              <a:rPr lang="en-US" baseline="0" dirty="0"/>
+              <a:t>It works well to just make the </a:t>
+            </a:r>
+            <a:r>
+              <a:rPr lang="en-US" baseline="0" dirty="0" err="1"/>
+              <a:t>ChessPiece</a:t>
+            </a:r>
+            <a:r>
+              <a:rPr lang="en-US" baseline="0" dirty="0"/>
+              <a:t> a class first and put in a </a:t>
+            </a:r>
+            <a:r>
+              <a:rPr lang="en-US" baseline="0" dirty="0" err="1"/>
+              <a:t>System.err.println</a:t>
+            </a:r>
+            <a:r>
+              <a:rPr lang="en-US" baseline="0" dirty="0"/>
+              <a:t>(“Implement this method!”) then show them if we forget to implement a method (Queen’s </a:t>
+            </a:r>
+            <a:r>
+              <a:rPr lang="en-US" baseline="0" dirty="0" err="1"/>
+              <a:t>checkMove</a:t>
+            </a:r>
+            <a:r>
+              <a:rPr lang="en-US" baseline="0" dirty="0"/>
+              <a:t>) we see that message at runtime.</a:t>
+            </a:r>
+          </a:p>
+          <a:p>
+            <a:endParaRPr lang="en-US" baseline="0" dirty="0"/>
+          </a:p>
+          <a:p>
+            <a:r>
+              <a:rPr lang="en-US" sz="1400" baseline="0" dirty="0"/>
+              <a:t>At this point, they should see the justification for an abstract class, show that on next slide</a:t>
+            </a:r>
+          </a:p>
+          <a:p>
             <a:endParaRPr lang="en-US" dirty="0"/>
           </a:p>
         </p:txBody>
@@ -2251,7 +1844,7 @@
     </p:spTree>
     <p:extLst>
       <p:ext uri="{BB962C8B-B14F-4D97-AF65-F5344CB8AC3E}">
-        <p14:creationId xmlns:p14="http://schemas.microsoft.com/office/powerpoint/2010/main" val="4079852235"/>
+        <p14:creationId xmlns:p14="http://schemas.microsoft.com/office/powerpoint/2010/main" val="220594822"/>
       </p:ext>
     </p:extLst>
   </p:cSld>
@@ -2306,25 +1899,522 @@
           <a:lstStyle/>
           <a:p>
             <a:r>
-              <a:rPr lang="en-US" dirty="0"/>
-              <a:t>Consider showing working version of the solution in the private repo or playing part of the final functionality video:</a:t>
-            </a:r>
-          </a:p>
-          <a:p>
+              <a:rPr lang="en-US" sz="1200" kern="1200" dirty="0">
+                <a:solidFill>
+                  <a:schemeClr val="tx1"/>
+                </a:solidFill>
+                <a:latin typeface="+mn-lt"/>
+                <a:ea typeface="+mn-ea"/>
+                <a:cs typeface="+mn-cs"/>
+              </a:rPr>
+              <a:t>Emphasize</a:t>
+            </a:r>
+            <a:r>
+              <a:rPr lang="en-US" sz="1200" kern="1200" baseline="0" dirty="0">
+                <a:solidFill>
+                  <a:schemeClr val="tx1"/>
+                </a:solidFill>
+                <a:latin typeface="+mn-lt"/>
+                <a:ea typeface="+mn-ea"/>
+                <a:cs typeface="+mn-cs"/>
+              </a:rPr>
+              <a:t> doing Pawn last it requires several things (</a:t>
+            </a:r>
+            <a:r>
+              <a:rPr lang="en-US" sz="1200" kern="1200" baseline="0" dirty="0" err="1">
+                <a:solidFill>
+                  <a:schemeClr val="tx1"/>
+                </a:solidFill>
+                <a:latin typeface="+mn-lt"/>
+                <a:ea typeface="+mn-ea"/>
+                <a:cs typeface="+mn-cs"/>
+              </a:rPr>
+              <a:t>hasMoved</a:t>
+            </a:r>
+            <a:r>
+              <a:rPr lang="en-US" sz="1200" kern="1200" baseline="0" dirty="0">
+                <a:solidFill>
+                  <a:schemeClr val="tx1"/>
+                </a:solidFill>
+                <a:latin typeface="+mn-lt"/>
+                <a:ea typeface="+mn-ea"/>
+                <a:cs typeface="+mn-cs"/>
+              </a:rPr>
+              <a:t> field) and needs to override the </a:t>
+            </a:r>
+            <a:r>
+              <a:rPr lang="en-US" sz="1200" kern="1200" baseline="0" dirty="0" err="1">
+                <a:solidFill>
+                  <a:schemeClr val="tx1"/>
+                </a:solidFill>
+                <a:latin typeface="+mn-lt"/>
+                <a:ea typeface="+mn-ea"/>
+                <a:cs typeface="+mn-cs"/>
+              </a:rPr>
+              <a:t>checkAttack</a:t>
+            </a:r>
+            <a:r>
+              <a:rPr lang="en-US" sz="1200" kern="1200" baseline="0" dirty="0">
+                <a:solidFill>
+                  <a:schemeClr val="tx1"/>
+                </a:solidFill>
+                <a:latin typeface="+mn-lt"/>
+                <a:ea typeface="+mn-ea"/>
+                <a:cs typeface="+mn-cs"/>
+              </a:rPr>
+              <a:t> method which is not obvious without looking at more code than they usually have to look at for the rest of the classes.</a:t>
+            </a:r>
+            <a:endParaRPr lang="en-US" sz="1200" kern="1200" dirty="0">
+              <a:solidFill>
+                <a:schemeClr val="tx1"/>
+              </a:solidFill>
+              <a:latin typeface="+mn-lt"/>
+              <a:ea typeface="+mn-ea"/>
+              <a:cs typeface="+mn-cs"/>
+            </a:endParaRPr>
+          </a:p>
+          <a:p>
+            <a:endParaRPr lang="en-US" sz="1200" kern="1200" dirty="0">
+              <a:solidFill>
+                <a:schemeClr val="tx1"/>
+              </a:solidFill>
+              <a:latin typeface="+mn-lt"/>
+              <a:ea typeface="+mn-ea"/>
+              <a:cs typeface="+mn-cs"/>
+            </a:endParaRPr>
+          </a:p>
+          <a:p>
+            <a:r>
+              <a:rPr lang="en-US" sz="1200" kern="1200" dirty="0">
+                <a:solidFill>
+                  <a:schemeClr val="tx1"/>
+                </a:solidFill>
+                <a:latin typeface="+mn-lt"/>
+                <a:ea typeface="+mn-ea"/>
+                <a:cs typeface="+mn-cs"/>
+              </a:rPr>
+              <a:t>@Override </a:t>
+            </a:r>
+          </a:p>
+          <a:p>
+            <a:r>
+              <a:rPr lang="en-US" sz="1200" b="1" kern="1200" dirty="0">
+                <a:solidFill>
+                  <a:schemeClr val="tx1"/>
+                </a:solidFill>
+                <a:latin typeface="+mn-lt"/>
+                <a:ea typeface="+mn-ea"/>
+                <a:cs typeface="+mn-cs"/>
+              </a:rPr>
+              <a:t>public </a:t>
+            </a:r>
+            <a:r>
+              <a:rPr lang="en-US" sz="1200" b="1" kern="1200" dirty="0" err="1">
+                <a:solidFill>
+                  <a:schemeClr val="tx1"/>
+                </a:solidFill>
+                <a:latin typeface="+mn-lt"/>
+                <a:ea typeface="+mn-ea"/>
+                <a:cs typeface="+mn-cs"/>
+              </a:rPr>
+              <a:t>boolean</a:t>
+            </a:r>
+            <a:r>
+              <a:rPr lang="en-US" sz="1200" b="1" kern="1200" dirty="0">
+                <a:solidFill>
+                  <a:schemeClr val="tx1"/>
+                </a:solidFill>
+                <a:latin typeface="+mn-lt"/>
+                <a:ea typeface="+mn-ea"/>
+                <a:cs typeface="+mn-cs"/>
+              </a:rPr>
+              <a:t> </a:t>
+            </a:r>
+            <a:r>
+              <a:rPr lang="en-US" sz="1200" b="1" kern="1200" dirty="0" err="1">
+                <a:solidFill>
+                  <a:schemeClr val="tx1"/>
+                </a:solidFill>
+                <a:latin typeface="+mn-lt"/>
+                <a:ea typeface="+mn-ea"/>
+                <a:cs typeface="+mn-cs"/>
+              </a:rPr>
+              <a:t>checkAttack</a:t>
+            </a:r>
+            <a:r>
+              <a:rPr lang="en-US" sz="1200" b="1" kern="1200" dirty="0">
+                <a:solidFill>
+                  <a:schemeClr val="tx1"/>
+                </a:solidFill>
+                <a:latin typeface="+mn-lt"/>
+                <a:ea typeface="+mn-ea"/>
+                <a:cs typeface="+mn-cs"/>
+              </a:rPr>
+              <a:t>(int dx, int </a:t>
+            </a:r>
+            <a:r>
+              <a:rPr lang="en-US" sz="1200" b="1" kern="1200" dirty="0" err="1">
+                <a:solidFill>
+                  <a:schemeClr val="tx1"/>
+                </a:solidFill>
+                <a:latin typeface="+mn-lt"/>
+                <a:ea typeface="+mn-ea"/>
+                <a:cs typeface="+mn-cs"/>
+              </a:rPr>
+              <a:t>dy</a:t>
+            </a:r>
+            <a:r>
+              <a:rPr lang="en-US" sz="1200" b="1" kern="1200" dirty="0">
+                <a:solidFill>
+                  <a:schemeClr val="tx1"/>
+                </a:solidFill>
+                <a:latin typeface="+mn-lt"/>
+                <a:ea typeface="+mn-ea"/>
+                <a:cs typeface="+mn-cs"/>
+              </a:rPr>
+              <a:t>, </a:t>
+            </a:r>
+            <a:r>
+              <a:rPr lang="en-US" sz="1200" b="1" kern="1200" dirty="0" err="1">
+                <a:solidFill>
+                  <a:schemeClr val="tx1"/>
+                </a:solidFill>
+                <a:latin typeface="+mn-lt"/>
+                <a:ea typeface="+mn-ea"/>
+                <a:cs typeface="+mn-cs"/>
+              </a:rPr>
+              <a:t>ChessPiece</a:t>
+            </a:r>
+            <a:r>
+              <a:rPr lang="en-US" sz="1200" b="1" kern="1200" dirty="0">
+                <a:solidFill>
+                  <a:schemeClr val="tx1"/>
+                </a:solidFill>
+                <a:latin typeface="+mn-lt"/>
+                <a:ea typeface="+mn-ea"/>
+                <a:cs typeface="+mn-cs"/>
+              </a:rPr>
+              <a:t> piece) {</a:t>
+            </a:r>
+          </a:p>
+          <a:p>
+            <a:r>
+              <a:rPr lang="en-US" sz="1200" b="1" kern="1200" dirty="0">
+                <a:solidFill>
+                  <a:schemeClr val="tx1"/>
+                </a:solidFill>
+                <a:latin typeface="+mn-lt"/>
+                <a:ea typeface="+mn-ea"/>
+                <a:cs typeface="+mn-cs"/>
+              </a:rPr>
+              <a:t>if (</a:t>
+            </a:r>
+            <a:r>
+              <a:rPr lang="en-US" sz="1200" b="1" kern="1200" dirty="0" err="1">
+                <a:solidFill>
+                  <a:schemeClr val="tx1"/>
+                </a:solidFill>
+                <a:latin typeface="+mn-lt"/>
+                <a:ea typeface="+mn-ea"/>
+                <a:cs typeface="+mn-cs"/>
+              </a:rPr>
+              <a:t>this.isWhite</a:t>
+            </a:r>
+            <a:r>
+              <a:rPr lang="en-US" sz="1200" b="1" kern="1200" dirty="0">
+                <a:solidFill>
+                  <a:schemeClr val="tx1"/>
+                </a:solidFill>
+                <a:latin typeface="+mn-lt"/>
+                <a:ea typeface="+mn-ea"/>
+                <a:cs typeface="+mn-cs"/>
+              </a:rPr>
+              <a:t>() == </a:t>
+            </a:r>
+            <a:r>
+              <a:rPr lang="en-US" sz="1200" b="1" kern="1200" dirty="0" err="1">
+                <a:solidFill>
+                  <a:schemeClr val="tx1"/>
+                </a:solidFill>
+                <a:latin typeface="+mn-lt"/>
+                <a:ea typeface="+mn-ea"/>
+                <a:cs typeface="+mn-cs"/>
+              </a:rPr>
+              <a:t>piece.isWhite</a:t>
+            </a:r>
+            <a:r>
+              <a:rPr lang="en-US" sz="1200" b="1" kern="1200" dirty="0">
+                <a:solidFill>
+                  <a:schemeClr val="tx1"/>
+                </a:solidFill>
+                <a:latin typeface="+mn-lt"/>
+                <a:ea typeface="+mn-ea"/>
+                <a:cs typeface="+mn-cs"/>
+              </a:rPr>
+              <a:t>()) {</a:t>
+            </a:r>
+          </a:p>
+          <a:p>
+            <a:r>
+              <a:rPr lang="en-US" sz="1200" b="1" kern="1200" dirty="0">
+                <a:solidFill>
+                  <a:schemeClr val="tx1"/>
+                </a:solidFill>
+                <a:latin typeface="+mn-lt"/>
+                <a:ea typeface="+mn-ea"/>
+                <a:cs typeface="+mn-cs"/>
+              </a:rPr>
+              <a:t>return false;</a:t>
+            </a:r>
+          </a:p>
+          <a:p>
+            <a:r>
+              <a:rPr lang="en-US" sz="1200" kern="1200" dirty="0">
+                <a:solidFill>
+                  <a:schemeClr val="tx1"/>
+                </a:solidFill>
+                <a:latin typeface="+mn-lt"/>
+                <a:ea typeface="+mn-ea"/>
+                <a:cs typeface="+mn-cs"/>
+              </a:rPr>
+              <a:t>}</a:t>
+            </a:r>
+          </a:p>
+          <a:p>
+            <a:r>
+              <a:rPr lang="en-US" sz="1200" b="1" kern="1200" dirty="0">
+                <a:solidFill>
+                  <a:schemeClr val="tx1"/>
+                </a:solidFill>
+                <a:latin typeface="+mn-lt"/>
+                <a:ea typeface="+mn-ea"/>
+                <a:cs typeface="+mn-cs"/>
+              </a:rPr>
+              <a:t>if (!</a:t>
+            </a:r>
+            <a:r>
+              <a:rPr lang="en-US" sz="1200" b="1" kern="1200" dirty="0" err="1">
+                <a:solidFill>
+                  <a:schemeClr val="tx1"/>
+                </a:solidFill>
+                <a:latin typeface="+mn-lt"/>
+                <a:ea typeface="+mn-ea"/>
+                <a:cs typeface="+mn-cs"/>
+              </a:rPr>
+              <a:t>movedCorrectDirection</a:t>
+            </a:r>
+            <a:r>
+              <a:rPr lang="en-US" sz="1200" b="1" kern="1200" dirty="0">
+                <a:solidFill>
+                  <a:schemeClr val="tx1"/>
+                </a:solidFill>
+                <a:latin typeface="+mn-lt"/>
+                <a:ea typeface="+mn-ea"/>
+                <a:cs typeface="+mn-cs"/>
+              </a:rPr>
+              <a:t>(</a:t>
+            </a:r>
+            <a:r>
+              <a:rPr lang="en-US" sz="1200" b="1" kern="1200" dirty="0" err="1">
+                <a:solidFill>
+                  <a:schemeClr val="tx1"/>
+                </a:solidFill>
+                <a:latin typeface="+mn-lt"/>
+                <a:ea typeface="+mn-ea"/>
+                <a:cs typeface="+mn-cs"/>
+              </a:rPr>
+              <a:t>dy</a:t>
+            </a:r>
+            <a:r>
+              <a:rPr lang="en-US" sz="1200" b="1" kern="1200" dirty="0">
+                <a:solidFill>
+                  <a:schemeClr val="tx1"/>
+                </a:solidFill>
+                <a:latin typeface="+mn-lt"/>
+                <a:ea typeface="+mn-ea"/>
+                <a:cs typeface="+mn-cs"/>
+              </a:rPr>
+              <a:t>)) {</a:t>
+            </a:r>
+          </a:p>
+          <a:p>
+            <a:r>
+              <a:rPr lang="en-US" sz="1200" b="1" kern="1200" dirty="0">
+                <a:solidFill>
+                  <a:schemeClr val="tx1"/>
+                </a:solidFill>
+                <a:latin typeface="+mn-lt"/>
+                <a:ea typeface="+mn-ea"/>
+                <a:cs typeface="+mn-cs"/>
+              </a:rPr>
+              <a:t>return false;</a:t>
+            </a:r>
+          </a:p>
+          <a:p>
+            <a:r>
+              <a:rPr lang="en-US" sz="1200" kern="1200" dirty="0">
+                <a:solidFill>
+                  <a:schemeClr val="tx1"/>
+                </a:solidFill>
+                <a:latin typeface="+mn-lt"/>
+                <a:ea typeface="+mn-ea"/>
+                <a:cs typeface="+mn-cs"/>
+              </a:rPr>
+              <a:t>}</a:t>
+            </a:r>
+          </a:p>
+          <a:p>
+            <a:r>
+              <a:rPr lang="en-US" sz="1200" kern="1200" dirty="0">
+                <a:solidFill>
+                  <a:schemeClr val="tx1"/>
+                </a:solidFill>
+                <a:latin typeface="+mn-lt"/>
+                <a:ea typeface="+mn-ea"/>
+                <a:cs typeface="+mn-cs"/>
+              </a:rPr>
+              <a:t>dx = </a:t>
+            </a:r>
+            <a:r>
+              <a:rPr lang="en-US" sz="1200" kern="1200" dirty="0" err="1">
+                <a:solidFill>
+                  <a:schemeClr val="tx1"/>
+                </a:solidFill>
+                <a:latin typeface="+mn-lt"/>
+                <a:ea typeface="+mn-ea"/>
+                <a:cs typeface="+mn-cs"/>
+              </a:rPr>
+              <a:t>Math.abs</a:t>
+            </a:r>
+            <a:r>
+              <a:rPr lang="en-US" sz="1200" kern="1200" dirty="0">
+                <a:solidFill>
+                  <a:schemeClr val="tx1"/>
+                </a:solidFill>
+                <a:latin typeface="+mn-lt"/>
+                <a:ea typeface="+mn-ea"/>
+                <a:cs typeface="+mn-cs"/>
+              </a:rPr>
+              <a:t>(dx);</a:t>
+            </a:r>
+          </a:p>
+          <a:p>
+            <a:r>
+              <a:rPr lang="en-US" sz="1200" kern="1200" dirty="0" err="1">
+                <a:solidFill>
+                  <a:schemeClr val="tx1"/>
+                </a:solidFill>
+                <a:latin typeface="+mn-lt"/>
+                <a:ea typeface="+mn-ea"/>
+                <a:cs typeface="+mn-cs"/>
+              </a:rPr>
+              <a:t>dy</a:t>
+            </a:r>
+            <a:r>
+              <a:rPr lang="en-US" sz="1200" kern="1200" dirty="0">
+                <a:solidFill>
+                  <a:schemeClr val="tx1"/>
+                </a:solidFill>
+                <a:latin typeface="+mn-lt"/>
+                <a:ea typeface="+mn-ea"/>
+                <a:cs typeface="+mn-cs"/>
+              </a:rPr>
+              <a:t> = </a:t>
+            </a:r>
+            <a:r>
+              <a:rPr lang="en-US" sz="1200" kern="1200" dirty="0" err="1">
+                <a:solidFill>
+                  <a:schemeClr val="tx1"/>
+                </a:solidFill>
+                <a:latin typeface="+mn-lt"/>
+                <a:ea typeface="+mn-ea"/>
+                <a:cs typeface="+mn-cs"/>
+              </a:rPr>
+              <a:t>Math.abs</a:t>
+            </a:r>
+            <a:r>
+              <a:rPr lang="en-US" sz="1200" kern="1200" dirty="0">
+                <a:solidFill>
+                  <a:schemeClr val="tx1"/>
+                </a:solidFill>
+                <a:latin typeface="+mn-lt"/>
+                <a:ea typeface="+mn-ea"/>
+                <a:cs typeface="+mn-cs"/>
+              </a:rPr>
+              <a:t>(</a:t>
+            </a:r>
+            <a:r>
+              <a:rPr lang="en-US" sz="1200" kern="1200" dirty="0" err="1">
+                <a:solidFill>
+                  <a:schemeClr val="tx1"/>
+                </a:solidFill>
+                <a:latin typeface="+mn-lt"/>
+                <a:ea typeface="+mn-ea"/>
+                <a:cs typeface="+mn-cs"/>
+              </a:rPr>
+              <a:t>dy</a:t>
+            </a:r>
+            <a:r>
+              <a:rPr lang="en-US" sz="1200" kern="1200" dirty="0">
+                <a:solidFill>
+                  <a:schemeClr val="tx1"/>
+                </a:solidFill>
+                <a:latin typeface="+mn-lt"/>
+                <a:ea typeface="+mn-ea"/>
+                <a:cs typeface="+mn-cs"/>
+              </a:rPr>
+              <a:t>);</a:t>
+            </a:r>
+          </a:p>
+          <a:p>
+            <a:r>
+              <a:rPr lang="en-US" sz="1200" b="1" kern="1200" dirty="0">
+                <a:solidFill>
+                  <a:schemeClr val="tx1"/>
+                </a:solidFill>
+                <a:latin typeface="+mn-lt"/>
+                <a:ea typeface="+mn-ea"/>
+                <a:cs typeface="+mn-cs"/>
+              </a:rPr>
+              <a:t>return dx == 1 &amp;&amp; </a:t>
+            </a:r>
+            <a:r>
+              <a:rPr lang="en-US" sz="1200" b="1" kern="1200" dirty="0" err="1">
+                <a:solidFill>
+                  <a:schemeClr val="tx1"/>
+                </a:solidFill>
+                <a:latin typeface="+mn-lt"/>
+                <a:ea typeface="+mn-ea"/>
+                <a:cs typeface="+mn-cs"/>
+              </a:rPr>
+              <a:t>dy</a:t>
+            </a:r>
+            <a:r>
+              <a:rPr lang="en-US" sz="1200" b="1" kern="1200" dirty="0">
+                <a:solidFill>
+                  <a:schemeClr val="tx1"/>
+                </a:solidFill>
+                <a:latin typeface="+mn-lt"/>
+                <a:ea typeface="+mn-ea"/>
+                <a:cs typeface="+mn-cs"/>
+              </a:rPr>
+              <a:t> == 1;</a:t>
+            </a:r>
+          </a:p>
+          <a:p>
+            <a:r>
+              <a:rPr lang="en-US" sz="1200" kern="1200" dirty="0">
+                <a:solidFill>
+                  <a:schemeClr val="tx1"/>
+                </a:solidFill>
+                <a:latin typeface="+mn-lt"/>
+                <a:ea typeface="+mn-ea"/>
+                <a:cs typeface="+mn-cs"/>
+              </a:rPr>
+              <a:t>}</a:t>
+            </a:r>
             <a:endParaRPr lang="en-US" dirty="0"/>
           </a:p>
-          <a:p>
-            <a:r>
-              <a:rPr lang="en-US" dirty="0"/>
-              <a:t>https://rose-hulman.hosted.panopto.com/Panopto/Pages/Viewer.aspx?id=c6958003-1803-436a-bc65-aba6002fdeb3</a:t>
-            </a:r>
-          </a:p>
-          <a:p>
-            <a:endParaRPr lang="en-US" dirty="0"/>
-          </a:p>
-          <a:p>
-            <a:endParaRPr lang="en-US" dirty="0"/>
-          </a:p>
         </p:txBody>
       </p:sp>
       <p:sp>
@@ -2334,7 +2424,7 @@
             <a:spLocks noGrp="1"/>
           </p:cNvSpPr>
           <p:nvPr>
-            <p:ph type="sldNum" sz="quarter" idx="5"/>
+            <p:ph type="sldNum" sz="quarter" idx="10"/>
           </p:nvPr>
         </p:nvSpPr>
         <p:spPr/>
@@ -2359,7 +2449,7 @@
     </p:spTree>
     <p:extLst>
       <p:ext uri="{BB962C8B-B14F-4D97-AF65-F5344CB8AC3E}">
-        <p14:creationId xmlns:p14="http://schemas.microsoft.com/office/powerpoint/2010/main" val="418949612"/>
+        <p14:creationId xmlns:p14="http://schemas.microsoft.com/office/powerpoint/2010/main" val="4079852235"/>
       </p:ext>
     </p:extLst>
   </p:cSld>
@@ -2410,12 +2500,28 @@
         </p:nvSpPr>
         <p:spPr/>
         <p:txBody>
-          <a:bodyPr>
-            <a:normAutofit/>
-          </a:bodyPr>
+          <a:bodyPr/>
           <a:lstStyle/>
           <a:p>
-            <a:endParaRPr lang="en-US"/>
+            <a:r>
+              <a:rPr lang="en-US" dirty="0"/>
+              <a:t>Consider showing working version of the solution in the private repo or playing part of the final functionality video:</a:t>
+            </a:r>
+          </a:p>
+          <a:p>
+            <a:endParaRPr lang="en-US" dirty="0"/>
+          </a:p>
+          <a:p>
+            <a:r>
+              <a:rPr lang="en-US" dirty="0"/>
+              <a:t>https://rose-hulman.hosted.panopto.com/Panopto/Pages/Viewer.aspx?id=c6958003-1803-436a-bc65-aba6002fdeb3</a:t>
+            </a:r>
+          </a:p>
+          <a:p>
+            <a:endParaRPr lang="en-US" dirty="0"/>
+          </a:p>
+          <a:p>
+            <a:endParaRPr lang="en-US" dirty="0"/>
           </a:p>
         </p:txBody>
       </p:sp>
@@ -2426,7 +2532,7 @@
             <a:spLocks noGrp="1"/>
           </p:cNvSpPr>
           <p:nvPr>
-            <p:ph type="sldNum" sz="quarter" idx="10"/>
+            <p:ph type="sldNum" sz="quarter" idx="5"/>
           </p:nvPr>
         </p:nvSpPr>
         <p:spPr/>
@@ -2451,7 +2557,7 @@
     </p:spTree>
     <p:extLst>
       <p:ext uri="{BB962C8B-B14F-4D97-AF65-F5344CB8AC3E}">
-        <p14:creationId xmlns:p14="http://schemas.microsoft.com/office/powerpoint/2010/main" val="254997008"/>
+        <p14:creationId xmlns:p14="http://schemas.microsoft.com/office/powerpoint/2010/main" val="418949612"/>
       </p:ext>
     </p:extLst>
   </p:cSld>
@@ -5765,7 +5871,7 @@
 </file>
 
 <file path=ppt/slides/slide10.xml><?xml version="1.0" encoding="utf-8"?>
-<p:sld xmlns:a="http://schemas.openxmlformats.org/drawingml/2006/main" xmlns:r="http://schemas.openxmlformats.org/officeDocument/2006/relationships" xmlns:p="http://schemas.openxmlformats.org/presentationml/2006/main" show="0">
+<p:sld xmlns:a="http://schemas.openxmlformats.org/drawingml/2006/main" xmlns:r="http://schemas.openxmlformats.org/officeDocument/2006/relationships" xmlns:p="http://schemas.openxmlformats.org/presentationml/2006/main">
   <p:cSld>
     <p:spTree>
       <p:nvGrpSpPr>
@@ -5783,7 +5889,7 @@
       </p:grpSpPr>
       <p:sp>
         <p:nvSpPr>
-          <p:cNvPr id="2" name="Title 1"/>
+          <p:cNvPr id="4" name="Title 3"/>
           <p:cNvSpPr>
             <a:spLocks noGrp="1"/>
           </p:cNvSpPr>
@@ -5793,128 +5899,105 @@
         </p:nvSpPr>
         <p:spPr/>
         <p:txBody>
+          <a:bodyPr/>
+          <a:lstStyle/>
+          <a:p>
+            <a:pPr>
+              <a:defRPr/>
+            </a:pPr>
+            <a:r>
+              <a:rPr lang="en-US"/>
+              <a:t>Work Time</a:t>
+            </a:r>
+          </a:p>
+        </p:txBody>
+      </p:sp>
+      <p:sp>
+        <p:nvSpPr>
+          <p:cNvPr id="24579" name="Text Placeholder 4"/>
+          <p:cNvSpPr>
+            <a:spLocks noGrp="1"/>
+          </p:cNvSpPr>
+          <p:nvPr>
+            <p:ph type="body" idx="1"/>
+          </p:nvPr>
+        </p:nvSpPr>
+        <p:spPr>
+          <a:xfrm>
+            <a:off x="722313" y="1828801"/>
+            <a:ext cx="7772400" cy="2578100"/>
+          </a:xfrm>
+        </p:spPr>
+        <p:txBody>
           <a:bodyPr>
-            <a:normAutofit fontScale="90000"/>
+            <a:normAutofit/>
           </a:bodyPr>
           <a:lstStyle/>
           <a:p>
             <a:r>
-              <a:rPr lang="en-US" dirty="0"/>
-              <a:t>If time allows:</a:t>
-            </a:r>
-            <a:br>
-              <a:rPr lang="en-US" dirty="0"/>
-            </a:br>
-            <a:r>
-              <a:rPr lang="en-US" dirty="0"/>
-              <a:t>Review of </a:t>
-            </a:r>
-            <a:r>
-              <a:rPr lang="en-US" dirty="0" err="1"/>
-              <a:t>BettingMain</a:t>
-            </a:r>
-            <a:r>
-              <a:rPr lang="en-US"/>
-              <a:t> Interface</a:t>
-            </a:r>
-            <a:endParaRPr lang="en-US" dirty="0"/>
-          </a:p>
-        </p:txBody>
-      </p:sp>
-      <p:pic>
-        <p:nvPicPr>
-          <p:cNvPr id="1026" name="Picture 2" descr="https://lh5.googleusercontent.com/vKRm2iF9VvcHXTnVzEvEgKtyjmLOG1GKyVtMwls6C8wLfYa_1LEeQMMn0_MpfL8NLdgWmCTPAFhxuroyh7Exb4ZrA3zh74kFEYp6Mp6pJW_vkdIeHTk9MGDLgZl0SDuH2Z1mM_dq">
-            <a:hlinkClick r:id="rId2"/>
-          </p:cNvPr>
-          <p:cNvPicPr>
-            <a:picLocks noGrp="1" noChangeAspect="1" noChangeArrowheads="1"/>
-          </p:cNvPicPr>
-          <p:nvPr>
-            <p:ph idx="1"/>
-          </p:nvPr>
-        </p:nvPicPr>
-        <p:blipFill>
-          <a:blip r:embed="rId3">
-            <a:extLst>
-              <a:ext uri="{28A0092B-C50C-407E-A947-70E740481C1C}">
-                <a14:useLocalDpi xmlns:a14="http://schemas.microsoft.com/office/drawing/2010/main" val="0"/>
-              </a:ext>
-            </a:extLst>
-          </a:blip>
-          <a:srcRect/>
-          <a:stretch>
-            <a:fillRect/>
-          </a:stretch>
-        </p:blipFill>
-        <p:spPr bwMode="auto">
+              <a:rPr lang="en-US" sz="2800" dirty="0"/>
+              <a:t>Chess</a:t>
+            </a:r>
+          </a:p>
+          <a:p>
+            <a:endParaRPr lang="en-US" sz="2800" dirty="0"/>
+          </a:p>
+          <a:p>
+            <a:endParaRPr lang="en-US" sz="2800" dirty="0"/>
+          </a:p>
+          <a:p>
+            <a:r>
+              <a:rPr lang="en-US" sz="2800" dirty="0"/>
+              <a:t>Ask instructor/assistants for help! </a:t>
+            </a:r>
+          </a:p>
+        </p:txBody>
+      </p:sp>
+      <p:sp>
+        <p:nvSpPr>
+          <p:cNvPr id="5" name="TextBox 4"/>
+          <p:cNvSpPr txBox="1"/>
+          <p:nvPr/>
+        </p:nvSpPr>
+        <p:spPr>
           <a:xfrm>
-            <a:off x="1825850" y="3485565"/>
-            <a:ext cx="5717949" cy="3103572"/>
+            <a:off x="7772400" y="6324600"/>
+            <a:ext cx="800219" cy="369332"/>
           </a:xfrm>
           <a:prstGeom prst="rect">
             <a:avLst/>
           </a:prstGeom>
-          <a:noFill/>
-          <a:extLst>
-            <a:ext uri="{909E8E84-426E-40DD-AFC4-6F175D3DCCD1}">
-              <a14:hiddenFill xmlns:a14="http://schemas.microsoft.com/office/drawing/2010/main">
-                <a:solidFill>
-                  <a:srgbClr val="FFFFFF"/>
-                </a:solidFill>
-              </a14:hiddenFill>
-            </a:ext>
-          </a:extLst>
         </p:spPr>
-      </p:pic>
-      <p:pic>
-        <p:nvPicPr>
-          <p:cNvPr id="1028" name="Picture 4" descr="https://lh4.googleusercontent.com/CrZ2wu3ZBZ7IeFOf4RM4FLifb955gTUKWqn-YSLtSWmC-2iu7W4e62tsXt7c_o1iip9WfGekBxQuYslNMZb0U3EEZ0wNYj69PXUlK_OUjaU1mgWzLbf92gFFZg7Nv4agh0XT7cMR">
-            <a:hlinkClick r:id="rId4"/>
-          </p:cNvPr>
-          <p:cNvPicPr>
-            <a:picLocks noChangeAspect="1" noChangeArrowheads="1"/>
-          </p:cNvPicPr>
-          <p:nvPr/>
-        </p:nvPicPr>
-        <p:blipFill>
-          <a:blip r:embed="rId5">
-            <a:extLst>
-              <a:ext uri="{28A0092B-C50C-407E-A947-70E740481C1C}">
-                <a14:useLocalDpi xmlns:a14="http://schemas.microsoft.com/office/drawing/2010/main" val="0"/>
-              </a:ext>
-            </a:extLst>
-          </a:blip>
-          <a:srcRect/>
-          <a:stretch>
-            <a:fillRect/>
-          </a:stretch>
-        </p:blipFill>
-        <p:spPr bwMode="auto">
-          <a:xfrm>
-            <a:off x="1600199" y="1417638"/>
-            <a:ext cx="5943600" cy="1533526"/>
-          </a:xfrm>
-          <a:prstGeom prst="rect">
-            <a:avLst/>
-          </a:prstGeom>
-          <a:noFill/>
-          <a:extLst>
-            <a:ext uri="{909E8E84-426E-40DD-AFC4-6F175D3DCCD1}">
-              <a14:hiddenFill xmlns:a14="http://schemas.microsoft.com/office/drawing/2010/main">
-                <a:solidFill>
-                  <a:srgbClr val="FFFFFF"/>
-                </a:solidFill>
-              </a14:hiddenFill>
-            </a:ext>
-          </a:extLst>
-        </p:spPr>
-      </p:pic>
+        <p:style>
+          <a:lnRef idx="2">
+            <a:schemeClr val="accent3">
+              <a:shade val="50000"/>
+            </a:schemeClr>
+          </a:lnRef>
+          <a:fillRef idx="1">
+            <a:schemeClr val="accent3"/>
+          </a:fillRef>
+          <a:effectRef idx="0">
+            <a:schemeClr val="accent3"/>
+          </a:effectRef>
+          <a:fontRef idx="minor">
+            <a:schemeClr val="lt1"/>
+          </a:fontRef>
+        </p:style>
+        <p:txBody>
+          <a:bodyPr wrap="none" rtlCol="0">
+            <a:spAutoFit/>
+          </a:bodyPr>
+          <a:lstStyle/>
+          <a:p>
+            <a:r>
+              <a:rPr lang="en-US"/>
+              <a:t>Q8-Q9</a:t>
+            </a:r>
+          </a:p>
+        </p:txBody>
+      </p:sp>
     </p:spTree>
-    <p:extLst>
-      <p:ext uri="{BB962C8B-B14F-4D97-AF65-F5344CB8AC3E}">
-        <p14:creationId xmlns:p14="http://schemas.microsoft.com/office/powerpoint/2010/main" val="3419082356"/>
-      </p:ext>
-    </p:extLst>
   </p:cSld>
   <p:clrMapOvr>
     <a:masterClrMapping/>
@@ -7716,8 +7799,173 @@
           <a:chExt cx="0" cy="0"/>
         </a:xfrm>
       </p:grpSpPr>
-      <mc:AlternateContent xmlns:mc="http://schemas.openxmlformats.org/markup-compatibility/2006">
-        <mc:Choice xmlns:a14="http://schemas.microsoft.com/office/drawing/2010/main" Requires="a14">
+      <p:sp>
+        <p:nvSpPr>
+          <p:cNvPr id="2" name="Title 1">
+            <a:extLst>
+              <a:ext uri="{FF2B5EF4-FFF2-40B4-BE49-F238E27FC236}">
+                <a16:creationId xmlns:a16="http://schemas.microsoft.com/office/drawing/2014/main" id="{AAB3AD40-1CED-47F2-7A01-ECC83F6162FD}"/>
+              </a:ext>
+            </a:extLst>
+          </p:cNvPr>
+          <p:cNvSpPr>
+            <a:spLocks noGrp="1"/>
+          </p:cNvSpPr>
+          <p:nvPr>
+            <p:ph type="title"/>
+          </p:nvPr>
+        </p:nvSpPr>
+        <p:spPr/>
+        <p:txBody>
+          <a:bodyPr/>
+          <a:lstStyle/>
+          <a:p>
+            <a:r>
+              <a:rPr lang="en-US" dirty="0"/>
+              <a:t>Explore: Shapes Demo</a:t>
+            </a:r>
+          </a:p>
+        </p:txBody>
+      </p:sp>
+      <p:sp>
+        <p:nvSpPr>
+          <p:cNvPr id="3" name="Content Placeholder 2">
+            <a:extLst>
+              <a:ext uri="{FF2B5EF4-FFF2-40B4-BE49-F238E27FC236}">
+                <a16:creationId xmlns:a16="http://schemas.microsoft.com/office/drawing/2014/main" id="{482673F1-1B58-966A-68E9-D2B84B7BD2CD}"/>
+              </a:ext>
+            </a:extLst>
+          </p:cNvPr>
+          <p:cNvSpPr>
+            <a:spLocks noGrp="1"/>
+          </p:cNvSpPr>
+          <p:nvPr>
+            <p:ph idx="1"/>
+          </p:nvPr>
+        </p:nvSpPr>
+        <p:spPr>
+          <a:xfrm>
+            <a:off x="457200" y="1600200"/>
+            <a:ext cx="8229600" cy="4983162"/>
+          </a:xfrm>
+        </p:spPr>
+        <p:txBody>
+          <a:bodyPr>
+            <a:normAutofit/>
+          </a:bodyPr>
+          <a:lstStyle/>
+          <a:p>
+            <a:r>
+              <a:rPr lang="en-US" sz="2800" dirty="0"/>
+              <a:t>In </a:t>
+            </a:r>
+            <a:r>
+              <a:rPr lang="en-US" sz="2800" i="1" dirty="0" err="1"/>
+              <a:t>PracticeAbstractClasses</a:t>
+            </a:r>
+            <a:r>
+              <a:rPr lang="en-US" sz="2800" dirty="0"/>
+              <a:t>, explore </a:t>
+            </a:r>
+            <a:r>
+              <a:rPr lang="en-US" sz="2800" i="1" dirty="0"/>
+              <a:t>shapes</a:t>
+            </a:r>
+            <a:r>
+              <a:rPr lang="en-US" sz="2800" dirty="0"/>
+              <a:t> pkg</a:t>
+            </a:r>
+          </a:p>
+          <a:p>
+            <a:r>
+              <a:rPr lang="en-US" sz="2800" dirty="0"/>
+              <a:t>What’s same/diff.: </a:t>
+            </a:r>
+            <a:r>
+              <a:rPr lang="en-US" sz="2800" dirty="0" err="1"/>
+              <a:t>AbstractShape</a:t>
+            </a:r>
+            <a:r>
+              <a:rPr lang="en-US" sz="2800" dirty="0"/>
+              <a:t> vs. Shape?</a:t>
+            </a:r>
+          </a:p>
+          <a:p>
+            <a:r>
+              <a:rPr lang="en-US" sz="2800" dirty="0"/>
+              <a:t>Why is abstract class &gt; interface here?</a:t>
+            </a:r>
+          </a:p>
+        </p:txBody>
+      </p:sp>
+      <p:pic>
+        <p:nvPicPr>
+          <p:cNvPr id="7" name="Picture 6">
+            <a:extLst>
+              <a:ext uri="{FF2B5EF4-FFF2-40B4-BE49-F238E27FC236}">
+                <a16:creationId xmlns:a16="http://schemas.microsoft.com/office/drawing/2014/main" id="{6FC718DA-CC21-6AE8-FD48-E46C512EFC41}"/>
+              </a:ext>
+            </a:extLst>
+          </p:cNvPr>
+          <p:cNvPicPr>
+            <a:picLocks noChangeAspect="1"/>
+          </p:cNvPicPr>
+          <p:nvPr/>
+        </p:nvPicPr>
+        <p:blipFill>
+          <a:blip r:embed="rId3">
+            <a:extLst>
+              <a:ext uri="{28A0092B-C50C-407E-A947-70E740481C1C}">
+                <a14:useLocalDpi xmlns:a14="http://schemas.microsoft.com/office/drawing/2010/main" val="0"/>
+              </a:ext>
+            </a:extLst>
+          </a:blip>
+          <a:stretch>
+            <a:fillRect/>
+          </a:stretch>
+        </p:blipFill>
+        <p:spPr>
+          <a:xfrm>
+            <a:off x="0" y="3164205"/>
+            <a:ext cx="9144000" cy="3648075"/>
+          </a:xfrm>
+          <a:prstGeom prst="rect">
+            <a:avLst/>
+          </a:prstGeom>
+        </p:spPr>
+      </p:pic>
+    </p:spTree>
+    <p:extLst>
+      <p:ext uri="{BB962C8B-B14F-4D97-AF65-F5344CB8AC3E}">
+        <p14:creationId xmlns:p14="http://schemas.microsoft.com/office/powerpoint/2010/main" val="2842103408"/>
+      </p:ext>
+    </p:extLst>
+  </p:cSld>
+  <p:clrMapOvr>
+    <a:masterClrMapping/>
+  </p:clrMapOvr>
+</p:sld>
+</file>
+
+<file path=ppt/slides/slide7.xml><?xml version="1.0" encoding="utf-8"?>
+<p:sld xmlns:a="http://schemas.openxmlformats.org/drawingml/2006/main" xmlns:r="http://schemas.openxmlformats.org/officeDocument/2006/relationships" xmlns:p="http://schemas.openxmlformats.org/presentationml/2006/main">
+  <p:cSld>
+    <p:spTree>
+      <p:nvGrpSpPr>
+        <p:cNvPr id="1" name=""/>
+        <p:cNvGrpSpPr/>
+        <p:nvPr/>
+      </p:nvGrpSpPr>
+      <p:grpSpPr>
+        <a:xfrm>
+          <a:off x="0" y="0"/>
+          <a:ext cx="0" cy="0"/>
+          <a:chOff x="0" y="0"/>
+          <a:chExt cx="0" cy="0"/>
+        </a:xfrm>
+      </p:grpSpPr>
+      <mc:AlternateContent xmlns:mc="http://schemas.openxmlformats.org/markup-compatibility/2006" xmlns:a14="http://schemas.microsoft.com/office/drawing/2010/main">
+        <mc:Choice Requires="a14">
           <p:sp>
             <p:nvSpPr>
               <p:cNvPr id="2" name="Title 1"/>
@@ -7757,7 +8005,7 @@
             </p:txBody>
           </p:sp>
         </mc:Choice>
-        <mc:Fallback>
+        <mc:Fallback xmlns="">
           <p:sp>
             <p:nvSpPr>
               <p:cNvPr id="2" name="Title 1"/>
@@ -8183,7 +8431,7 @@
 </p:sld>
 </file>
 
-<file path=ppt/slides/slide7.xml><?xml version="1.0" encoding="utf-8"?>
+<file path=ppt/slides/slide8.xml><?xml version="1.0" encoding="utf-8"?>
 <p:sld xmlns:a="http://schemas.openxmlformats.org/drawingml/2006/main" xmlns:r="http://schemas.openxmlformats.org/officeDocument/2006/relationships" xmlns:p="http://schemas.openxmlformats.org/presentationml/2006/main">
   <p:cSld>
     <p:spTree>
@@ -8302,7 +8550,7 @@
 </p:sld>
 </file>
 
-<file path=ppt/slides/slide8.xml><?xml version="1.0" encoding="utf-8"?>
+<file path=ppt/slides/slide9.xml><?xml version="1.0" encoding="utf-8"?>
 <p:sld xmlns:a="http://schemas.openxmlformats.org/drawingml/2006/main" xmlns:r="http://schemas.openxmlformats.org/officeDocument/2006/relationships" xmlns:p="http://schemas.openxmlformats.org/presentationml/2006/main">
   <p:cSld>
     <p:spTree>
@@ -8438,141 +8686,6 @@
         <p14:creationId xmlns:p14="http://schemas.microsoft.com/office/powerpoint/2010/main" val="2283330882"/>
       </p:ext>
     </p:extLst>
-  </p:cSld>
-  <p:clrMapOvr>
-    <a:masterClrMapping/>
-  </p:clrMapOvr>
-</p:sld>
-</file>
-
-<file path=ppt/slides/slide9.xml><?xml version="1.0" encoding="utf-8"?>
-<p:sld xmlns:a="http://schemas.openxmlformats.org/drawingml/2006/main" xmlns:r="http://schemas.openxmlformats.org/officeDocument/2006/relationships" xmlns:p="http://schemas.openxmlformats.org/presentationml/2006/main">
-  <p:cSld>
-    <p:spTree>
-      <p:nvGrpSpPr>
-        <p:cNvPr id="1" name=""/>
-        <p:cNvGrpSpPr/>
-        <p:nvPr/>
-      </p:nvGrpSpPr>
-      <p:grpSpPr>
-        <a:xfrm>
-          <a:off x="0" y="0"/>
-          <a:ext cx="0" cy="0"/>
-          <a:chOff x="0" y="0"/>
-          <a:chExt cx="0" cy="0"/>
-        </a:xfrm>
-      </p:grpSpPr>
-      <p:sp>
-        <p:nvSpPr>
-          <p:cNvPr id="4" name="Title 3"/>
-          <p:cNvSpPr>
-            <a:spLocks noGrp="1"/>
-          </p:cNvSpPr>
-          <p:nvPr>
-            <p:ph type="title"/>
-          </p:nvPr>
-        </p:nvSpPr>
-        <p:spPr/>
-        <p:txBody>
-          <a:bodyPr/>
-          <a:lstStyle/>
-          <a:p>
-            <a:pPr>
-              <a:defRPr/>
-            </a:pPr>
-            <a:r>
-              <a:rPr lang="en-US"/>
-              <a:t>Work Time</a:t>
-            </a:r>
-          </a:p>
-        </p:txBody>
-      </p:sp>
-      <p:sp>
-        <p:nvSpPr>
-          <p:cNvPr id="24579" name="Text Placeholder 4"/>
-          <p:cNvSpPr>
-            <a:spLocks noGrp="1"/>
-          </p:cNvSpPr>
-          <p:nvPr>
-            <p:ph type="body" idx="1"/>
-          </p:nvPr>
-        </p:nvSpPr>
-        <p:spPr>
-          <a:xfrm>
-            <a:off x="722313" y="1828801"/>
-            <a:ext cx="7772400" cy="2578100"/>
-          </a:xfrm>
-        </p:spPr>
-        <p:txBody>
-          <a:bodyPr>
-            <a:normAutofit/>
-          </a:bodyPr>
-          <a:lstStyle/>
-          <a:p>
-            <a:r>
-              <a:rPr lang="en-US" sz="2800" dirty="0"/>
-              <a:t>Chess</a:t>
-            </a:r>
-          </a:p>
-          <a:p>
-            <a:endParaRPr lang="en-US" sz="2800" dirty="0"/>
-          </a:p>
-          <a:p>
-            <a:endParaRPr lang="en-US" sz="2800" dirty="0"/>
-          </a:p>
-          <a:p>
-            <a:r>
-              <a:rPr lang="en-US" sz="2800" dirty="0"/>
-              <a:t>Ask instructor/assistants for help! </a:t>
-            </a:r>
-          </a:p>
-        </p:txBody>
-      </p:sp>
-      <p:sp>
-        <p:nvSpPr>
-          <p:cNvPr id="5" name="TextBox 4"/>
-          <p:cNvSpPr txBox="1"/>
-          <p:nvPr/>
-        </p:nvSpPr>
-        <p:spPr>
-          <a:xfrm>
-            <a:off x="7772400" y="6324600"/>
-            <a:ext cx="800219" cy="369332"/>
-          </a:xfrm>
-          <a:prstGeom prst="rect">
-            <a:avLst/>
-          </a:prstGeom>
-        </p:spPr>
-        <p:style>
-          <a:lnRef idx="2">
-            <a:schemeClr val="accent3">
-              <a:shade val="50000"/>
-            </a:schemeClr>
-          </a:lnRef>
-          <a:fillRef idx="1">
-            <a:schemeClr val="accent3"/>
-          </a:fillRef>
-          <a:effectRef idx="0">
-            <a:schemeClr val="accent3"/>
-          </a:effectRef>
-          <a:fontRef idx="minor">
-            <a:schemeClr val="lt1"/>
-          </a:fontRef>
-        </p:style>
-        <p:txBody>
-          <a:bodyPr wrap="none" rtlCol="0">
-            <a:spAutoFit/>
-          </a:bodyPr>
-          <a:lstStyle/>
-          <a:p>
-            <a:r>
-              <a:rPr lang="en-US"/>
-              <a:t>Q8-Q9</a:t>
-            </a:r>
-          </a:p>
-        </p:txBody>
-      </p:sp>
-    </p:spTree>
   </p:cSld>
   <p:clrMapOvr>
     <a:masterClrMapping/>
@@ -9369,18 +9482,18 @@
 </file>
 
 <file path=customXml/item1.xml><?xml version="1.0" encoding="utf-8"?>
+<p:properties xmlns:p="http://schemas.microsoft.com/office/2006/metadata/properties" xmlns:xsi="http://www.w3.org/2001/XMLSchema-instance" xmlns:pc="http://schemas.microsoft.com/office/infopath/2007/PartnerControls">
+  <documentManagement/>
+</p:properties>
+</file>
+
+<file path=customXml/item2.xml><?xml version="1.0" encoding="utf-8"?>
 <?mso-contentType ?>
 <FormTemplates xmlns="http://schemas.microsoft.com/sharepoint/v3/contenttype/forms">
   <Display>DocumentLibraryForm</Display>
   <Edit>DocumentLibraryForm</Edit>
   <New>DocumentLibraryForm</New>
 </FormTemplates>
-</file>
-
-<file path=customXml/item2.xml><?xml version="1.0" encoding="utf-8"?>
-<p:properties xmlns:p="http://schemas.microsoft.com/office/2006/metadata/properties" xmlns:xsi="http://www.w3.org/2001/XMLSchema-instance" xmlns:pc="http://schemas.microsoft.com/office/infopath/2007/PartnerControls">
-  <documentManagement/>
-</p:properties>
 </file>
 
 <file path=customXml/item3.xml><?xml version="1.0" encoding="utf-8"?>
@@ -9554,18 +9667,18 @@
 </file>
 
 <file path=customXml/itemProps1.xml><?xml version="1.0" encoding="utf-8"?>
-<ds:datastoreItem xmlns:ds="http://schemas.openxmlformats.org/officeDocument/2006/customXml" ds:itemID="{3C4378FB-03E6-44FD-B96F-DE665721A11C}">
+<ds:datastoreItem xmlns:ds="http://schemas.openxmlformats.org/officeDocument/2006/customXml" ds:itemID="{72D20C57-C3B5-47E7-874B-37927E7B7865}">
   <ds:schemaRefs>
-    <ds:schemaRef ds:uri="http://schemas.microsoft.com/sharepoint/v3/contenttype/forms"/>
+    <ds:schemaRef ds:uri="http://schemas.microsoft.com/office/2006/metadata/properties"/>
+    <ds:schemaRef ds:uri="http://schemas.microsoft.com/office/infopath/2007/PartnerControls"/>
   </ds:schemaRefs>
 </ds:datastoreItem>
 </file>
 
 <file path=customXml/itemProps2.xml><?xml version="1.0" encoding="utf-8"?>
-<ds:datastoreItem xmlns:ds="http://schemas.openxmlformats.org/officeDocument/2006/customXml" ds:itemID="{72D20C57-C3B5-47E7-874B-37927E7B7865}">
+<ds:datastoreItem xmlns:ds="http://schemas.openxmlformats.org/officeDocument/2006/customXml" ds:itemID="{3C4378FB-03E6-44FD-B96F-DE665721A11C}">
   <ds:schemaRefs>
-    <ds:schemaRef ds:uri="http://schemas.microsoft.com/office/2006/metadata/properties"/>
-    <ds:schemaRef ds:uri="http://schemas.microsoft.com/office/infopath/2007/PartnerControls"/>
+    <ds:schemaRef ds:uri="http://schemas.microsoft.com/sharepoint/v3/contenttype/forms"/>
   </ds:schemaRefs>
 </ds:datastoreItem>
 </file>

</xml_diff>